<commit_message>
Test for Syntax Tree finish
</commit_message>
<xml_diff>
--- a/doc/K2Projectpptx.pptx
+++ b/doc/K2Projectpptx.pptx
@@ -7526,7 +7526,7 @@
         </p:nvGrpSpPr>
         <p:grpSpPr>
           <a:xfrm>
-            <a:off x="1006517" y="3442034"/>
+            <a:off x="272794" y="3951675"/>
             <a:ext cx="1869440" cy="875545"/>
             <a:chOff x="996357" y="629920"/>
             <a:chExt cx="1869440" cy="875545"/>
@@ -7669,7 +7669,7 @@
         </p:nvGrpSpPr>
         <p:grpSpPr>
           <a:xfrm>
-            <a:off x="2347637" y="3442034"/>
+            <a:off x="1613914" y="3951675"/>
             <a:ext cx="1869440" cy="875545"/>
             <a:chOff x="996357" y="629920"/>
             <a:chExt cx="1869440" cy="875545"/>
@@ -7695,6 +7695,9 @@
             <a:prstGeom prst="ellipse">
               <a:avLst/>
             </a:prstGeom>
+            <a:solidFill>
+              <a:srgbClr val="00B050"/>
+            </a:solidFill>
           </p:spPr>
           <p:style>
             <a:lnRef idx="2">
@@ -7752,7 +7755,7 @@
               <a:pPr algn="ctr"/>
               <a:r>
                 <a:rPr lang="it-IT" dirty="0"/>
-                <a:t>ast.rs</a:t>
+                <a:t>syntax_tree.rs</a:t>
               </a:r>
             </a:p>
           </p:txBody>
@@ -7772,7 +7775,7 @@
         </p:nvGrpSpPr>
         <p:grpSpPr>
           <a:xfrm>
-            <a:off x="2347637" y="4573981"/>
+            <a:off x="2819397" y="3951675"/>
             <a:ext cx="1869440" cy="875545"/>
             <a:chOff x="996357" y="629920"/>
             <a:chExt cx="1869440" cy="875545"/>
@@ -7875,10 +7878,10 @@
         </p:nvGrpSpPr>
         <p:grpSpPr>
           <a:xfrm>
-            <a:off x="4617041" y="3603361"/>
-            <a:ext cx="1869440" cy="896821"/>
-            <a:chOff x="1396321" y="281739"/>
-            <a:chExt cx="1869440" cy="896821"/>
+            <a:off x="4193538" y="3478168"/>
+            <a:ext cx="1869440" cy="1022014"/>
+            <a:chOff x="972818" y="156546"/>
+            <a:chExt cx="1869440" cy="1022014"/>
           </a:xfrm>
         </p:grpSpPr>
         <p:sp>
@@ -7941,7 +7944,7 @@
           </p:nvSpPr>
           <p:spPr>
             <a:xfrm>
-              <a:off x="1396321" y="281739"/>
+              <a:off x="972818" y="156546"/>
               <a:ext cx="1869440" cy="369332"/>
             </a:xfrm>
             <a:prstGeom prst="rect">
@@ -7981,95 +7984,10 @@
         </p:nvCxnSpPr>
         <p:spPr>
           <a:xfrm>
-            <a:off x="2251117" y="3716354"/>
+            <a:off x="1517394" y="4225995"/>
             <a:ext cx="721360" cy="0"/>
           </a:xfrm>
           <a:prstGeom prst="straightConnector1">
-            <a:avLst/>
-          </a:prstGeom>
-          <a:ln>
-            <a:tailEnd type="triangle"/>
-          </a:ln>
-        </p:spPr>
-        <p:style>
-          <a:lnRef idx="2">
-            <a:schemeClr val="accent1"/>
-          </a:lnRef>
-          <a:fillRef idx="0">
-            <a:schemeClr val="accent1"/>
-          </a:fillRef>
-          <a:effectRef idx="1">
-            <a:schemeClr val="accent1"/>
-          </a:effectRef>
-          <a:fontRef idx="minor">
-            <a:schemeClr val="tx1"/>
-          </a:fontRef>
-        </p:style>
-      </p:cxnSp>
-      <p:cxnSp>
-        <p:nvCxnSpPr>
-          <p:cNvPr id="47" name="Connettore a gomito 46">
-            <a:extLst>
-              <a:ext uri="{FF2B5EF4-FFF2-40B4-BE49-F238E27FC236}">
-                <a16:creationId xmlns:a16="http://schemas.microsoft.com/office/drawing/2014/main" id="{B8AB251D-3E1E-18C9-713A-DC94966934CF}"/>
-              </a:ext>
-            </a:extLst>
-          </p:cNvPr>
-          <p:cNvCxnSpPr>
-            <a:cxnSpLocks/>
-            <a:stCxn id="3" idx="6"/>
-            <a:endCxn id="21" idx="1"/>
-          </p:cNvCxnSpPr>
-          <p:nvPr/>
-        </p:nvCxnSpPr>
-        <p:spPr>
-          <a:xfrm>
-            <a:off x="3592237" y="3716354"/>
-            <a:ext cx="1340442" cy="315534"/>
-          </a:xfrm>
-          <a:prstGeom prst="bentConnector2">
-            <a:avLst/>
-          </a:prstGeom>
-          <a:ln>
-            <a:tailEnd type="triangle"/>
-          </a:ln>
-        </p:spPr>
-        <p:style>
-          <a:lnRef idx="2">
-            <a:schemeClr val="accent1"/>
-          </a:lnRef>
-          <a:fillRef idx="0">
-            <a:schemeClr val="accent1"/>
-          </a:fillRef>
-          <a:effectRef idx="1">
-            <a:schemeClr val="accent1"/>
-          </a:effectRef>
-          <a:fontRef idx="minor">
-            <a:schemeClr val="tx1"/>
-          </a:fontRef>
-        </p:style>
-      </p:cxnSp>
-      <p:cxnSp>
-        <p:nvCxnSpPr>
-          <p:cNvPr id="50" name="Connettore a gomito 49">
-            <a:extLst>
-              <a:ext uri="{FF2B5EF4-FFF2-40B4-BE49-F238E27FC236}">
-                <a16:creationId xmlns:a16="http://schemas.microsoft.com/office/drawing/2014/main" id="{2BD68FD1-9AC5-775A-EF32-925406529C11}"/>
-              </a:ext>
-            </a:extLst>
-          </p:cNvPr>
-          <p:cNvCxnSpPr>
-            <a:stCxn id="6" idx="6"/>
-            <a:endCxn id="21" idx="3"/>
-          </p:cNvCxnSpPr>
-          <p:nvPr/>
-        </p:nvCxnSpPr>
-        <p:spPr>
-          <a:xfrm flipV="1">
-            <a:off x="3592237" y="4419836"/>
-            <a:ext cx="1340442" cy="428465"/>
-          </a:xfrm>
-          <a:prstGeom prst="bentConnector2">
             <a:avLst/>
           </a:prstGeom>
           <a:ln>
@@ -8188,7 +8106,7 @@
               <a:pPr algn="ctr"/>
               <a:r>
                 <a:rPr lang="it-IT" dirty="0"/>
-                <a:t>ast.rs</a:t>
+                <a:t>syntax_tree.rs</a:t>
               </a:r>
             </a:p>
           </p:txBody>
@@ -9094,6 +9012,90 @@
           </p:sp>
         </p:grpSp>
       </p:grpSp>
+      <p:cxnSp>
+        <p:nvCxnSpPr>
+          <p:cNvPr id="13" name="Connettore 2 12">
+            <a:extLst>
+              <a:ext uri="{FF2B5EF4-FFF2-40B4-BE49-F238E27FC236}">
+                <a16:creationId xmlns:a16="http://schemas.microsoft.com/office/drawing/2014/main" id="{AE4DA920-7DEF-1142-C314-3804B73C5A77}"/>
+              </a:ext>
+            </a:extLst>
+          </p:cNvPr>
+          <p:cNvCxnSpPr>
+            <a:stCxn id="6" idx="6"/>
+            <a:endCxn id="21" idx="2"/>
+          </p:cNvCxnSpPr>
+          <p:nvPr/>
+        </p:nvCxnSpPr>
+        <p:spPr>
+          <a:xfrm flipV="1">
+            <a:off x="4063997" y="4225862"/>
+            <a:ext cx="777920" cy="133"/>
+          </a:xfrm>
+          <a:prstGeom prst="straightConnector1">
+            <a:avLst/>
+          </a:prstGeom>
+          <a:ln>
+            <a:tailEnd type="triangle"/>
+          </a:ln>
+        </p:spPr>
+        <p:style>
+          <a:lnRef idx="2">
+            <a:schemeClr val="accent1"/>
+          </a:lnRef>
+          <a:fillRef idx="0">
+            <a:schemeClr val="accent1"/>
+          </a:fillRef>
+          <a:effectRef idx="1">
+            <a:schemeClr val="accent1"/>
+          </a:effectRef>
+          <a:fontRef idx="minor">
+            <a:schemeClr val="tx1"/>
+          </a:fontRef>
+        </p:style>
+      </p:cxnSp>
+      <p:cxnSp>
+        <p:nvCxnSpPr>
+          <p:cNvPr id="15" name="Connettore 2 14">
+            <a:extLst>
+              <a:ext uri="{FF2B5EF4-FFF2-40B4-BE49-F238E27FC236}">
+                <a16:creationId xmlns:a16="http://schemas.microsoft.com/office/drawing/2014/main" id="{678F840E-62C3-B621-ED0F-E9DC0E6254BC}"/>
+              </a:ext>
+            </a:extLst>
+          </p:cNvPr>
+          <p:cNvCxnSpPr>
+            <a:stCxn id="3" idx="6"/>
+            <a:endCxn id="6" idx="2"/>
+          </p:cNvCxnSpPr>
+          <p:nvPr/>
+        </p:nvCxnSpPr>
+        <p:spPr>
+          <a:xfrm>
+            <a:off x="2858514" y="4225995"/>
+            <a:ext cx="585723" cy="0"/>
+          </a:xfrm>
+          <a:prstGeom prst="straightConnector1">
+            <a:avLst/>
+          </a:prstGeom>
+          <a:ln>
+            <a:tailEnd type="triangle"/>
+          </a:ln>
+        </p:spPr>
+        <p:style>
+          <a:lnRef idx="2">
+            <a:schemeClr val="accent1"/>
+          </a:lnRef>
+          <a:fillRef idx="0">
+            <a:schemeClr val="accent1"/>
+          </a:fillRef>
+          <a:effectRef idx="1">
+            <a:schemeClr val="accent1"/>
+          </a:effectRef>
+          <a:fontRef idx="minor">
+            <a:schemeClr val="tx1"/>
+          </a:fontRef>
+        </p:style>
+      </p:cxnSp>
     </p:spTree>
     <p:extLst>
       <p:ext uri="{BB962C8B-B14F-4D97-AF65-F5344CB8AC3E}">

</xml_diff>